<commit_message>
Gráficos de Excel, Word y PowerPoint dibujados en SVG; ecuaciones de Word como texto
Columnas, barras (agrupadas, apiladas, al 100 %), líneas, áreas, sectores, anillos y dispersión,
con título, ejes, rejilla, leyenda y etiquetas de datos. Los gráficos sin datos en caché
(openpyxl, XlsxWriter) se completan leyendo las celdas. En Excel, los gráficos e imágenes se
colocan sobre las celdas en las que están anclados.

Co-Authored-By: Claude Sonnet 5.5 <noreply@anthropic.com>
Claude-Session: https://claude.ai/code/session_01MNQ3cZTHgxewBkKhBCN5vB
</commit_message>
<xml_diff>
--- a/tests/fixtures/office/presentacion.pptx
+++ b/tests/fixtures/office/presentacion.pptx
@@ -10,6 +10,7 @@
     <p:sldId id="258" r:id="rId9"/>
     <p:sldId id="259" r:id="rId10"/>
     <p:sldId id="260" r:id="rId11"/>
+    <p:sldId id="261" r:id="rId12"/>
   </p:sldIdLst>
   <p:sldSz cx="12191695" cy="6858000" type="screen4x3"/>
   <p:notesSz cx="6858000" cy="9144000"/>
@@ -109,6 +110,287 @@
     </a:lvl9pPr>
   </p:defaultTextStyle>
 </p:presentation>
+</file>
+
+<file path=ppt/charts/chart1.xml><?xml version="1.0" encoding="utf-8"?>
+<c:chartSpace xmlns:c="http://schemas.openxmlformats.org/drawingml/2006/chart" xmlns:a="http://schemas.openxmlformats.org/drawingml/2006/main" xmlns:r="http://schemas.openxmlformats.org/officeDocument/2006/relationships">
+  <c:date1904 val="0"/>
+  <c:chart>
+    <c:title>
+      <c:tx>
+        <c:rich>
+          <a:bodyPr/>
+          <a:lstStyle/>
+          <a:p>
+            <a:r>
+              <a:t>Ventas por zona</a:t>
+            </a:r>
+          </a:p>
+        </c:rich>
+      </c:tx>
+      <c:layout/>
+      <c:overlay val="0"/>
+    </c:title>
+    <c:autoTitleDeleted val="0"/>
+    <c:plotArea>
+      <c:barChart>
+        <c:barDir val="col"/>
+        <c:grouping val="clustered"/>
+        <c:ser>
+          <c:idx val="0"/>
+          <c:order val="0"/>
+          <c:tx>
+            <c:strRef>
+              <c:f>Sheet1!$B$1</c:f>
+              <c:strCache>
+                <c:ptCount val="1"/>
+                <c:pt idx="0">
+                  <c:v>2023</c:v>
+                </c:pt>
+              </c:strCache>
+            </c:strRef>
+          </c:tx>
+          <c:cat>
+            <c:strRef>
+              <c:f>Sheet1!$A$2:$A$5</c:f>
+              <c:strCache>
+                <c:ptCount val="4"/>
+                <c:pt idx="0">
+                  <c:v>Norte</c:v>
+                </c:pt>
+                <c:pt idx="1">
+                  <c:v>Sur</c:v>
+                </c:pt>
+                <c:pt idx="2">
+                  <c:v>Este</c:v>
+                </c:pt>
+                <c:pt idx="3">
+                  <c:v>Oeste</c:v>
+                </c:pt>
+              </c:strCache>
+            </c:strRef>
+          </c:cat>
+          <c:val>
+            <c:numRef>
+              <c:f>Sheet1!$B$2:$B$5</c:f>
+              <c:numCache>
+                <c:formatCode>General</c:formatCode>
+                <c:ptCount val="4"/>
+                <c:pt idx="0">
+                  <c:v>19.2</c:v>
+                </c:pt>
+                <c:pt idx="1">
+                  <c:v>21.4</c:v>
+                </c:pt>
+                <c:pt idx="2">
+                  <c:v>16.7</c:v>
+                </c:pt>
+                <c:pt idx="3">
+                  <c:v>12.9</c:v>
+                </c:pt>
+              </c:numCache>
+            </c:numRef>
+          </c:val>
+        </c:ser>
+        <c:ser>
+          <c:idx val="1"/>
+          <c:order val="1"/>
+          <c:tx>
+            <c:strRef>
+              <c:f>Sheet1!$C$1</c:f>
+              <c:strCache>
+                <c:ptCount val="1"/>
+                <c:pt idx="0">
+                  <c:v>2024</c:v>
+                </c:pt>
+              </c:strCache>
+            </c:strRef>
+          </c:tx>
+          <c:cat>
+            <c:strRef>
+              <c:f>Sheet1!$A$2:$A$5</c:f>
+              <c:strCache>
+                <c:ptCount val="4"/>
+                <c:pt idx="0">
+                  <c:v>Norte</c:v>
+                </c:pt>
+                <c:pt idx="1">
+                  <c:v>Sur</c:v>
+                </c:pt>
+                <c:pt idx="2">
+                  <c:v>Este</c:v>
+                </c:pt>
+                <c:pt idx="3">
+                  <c:v>Oeste</c:v>
+                </c:pt>
+              </c:strCache>
+            </c:strRef>
+          </c:cat>
+          <c:val>
+            <c:numRef>
+              <c:f>Sheet1!$C$2:$C$5</c:f>
+              <c:numCache>
+                <c:formatCode>General</c:formatCode>
+                <c:ptCount val="4"/>
+                <c:pt idx="0">
+                  <c:v>22.3</c:v>
+                </c:pt>
+                <c:pt idx="1">
+                  <c:v>18.2</c:v>
+                </c:pt>
+                <c:pt idx="2">
+                  <c:v>21.1</c:v>
+                </c:pt>
+                <c:pt idx="3">
+                  <c:v>15.6</c:v>
+                </c:pt>
+              </c:numCache>
+            </c:numRef>
+          </c:val>
+        </c:ser>
+        <c:axId val="-2068027336"/>
+        <c:axId val="-2113994440"/>
+      </c:barChart>
+      <c:catAx>
+        <c:axId val="-2068027336"/>
+        <c:scaling>
+          <c:orientation val="minMax"/>
+        </c:scaling>
+        <c:delete val="0"/>
+        <c:axPos val="b"/>
+        <c:majorTickMark val="out"/>
+        <c:minorTickMark val="none"/>
+        <c:tickLblPos val="nextTo"/>
+        <c:crossAx val="-2113994440"/>
+        <c:crosses val="autoZero"/>
+        <c:auto val="1"/>
+        <c:lblAlgn val="ctr"/>
+        <c:lblOffset val="100"/>
+        <c:noMultiLvlLbl val="0"/>
+      </c:catAx>
+      <c:valAx>
+        <c:axId val="-2113994440"/>
+        <c:scaling/>
+        <c:delete val="0"/>
+        <c:axPos val="l"/>
+        <c:majorGridlines/>
+        <c:majorTickMark val="out"/>
+        <c:minorTickMark val="none"/>
+        <c:tickLblPos val="nextTo"/>
+        <c:crossAx val="-2068027336"/>
+        <c:crosses val="autoZero"/>
+      </c:valAx>
+    </c:plotArea>
+    <c:legend>
+      <c:legendPos val="b"/>
+      <c:overlay val="0"/>
+    </c:legend>
+    <c:dispBlanksAs val="gap"/>
+  </c:chart>
+  <c:txPr>
+    <a:bodyPr/>
+    <a:lstStyle/>
+    <a:p>
+      <a:pPr>
+        <a:defRPr sz="1800"/>
+      </a:pPr>
+      <a:endParaRPr lang="en-US"/>
+    </a:p>
+  </c:txPr>
+  <c:externalData r:id="rId1">
+    <c:autoUpdate val="0"/>
+  </c:externalData>
+</c:chartSpace>
+</file>
+
+<file path=ppt/charts/chart2.xml><?xml version="1.0" encoding="utf-8"?>
+<c:chartSpace xmlns:c="http://schemas.openxmlformats.org/drawingml/2006/chart" xmlns:a="http://schemas.openxmlformats.org/drawingml/2006/main" xmlns:r="http://schemas.openxmlformats.org/officeDocument/2006/relationships">
+  <c:chart>
+    <c:autoTitleDeleted val="0"/>
+    <c:plotArea>
+      <c:pieChart>
+        <c:varyColors val="1"/>
+        <c:ser>
+          <c:idx val="0"/>
+          <c:order val="0"/>
+          <c:tx>
+            <c:strRef>
+              <c:f>Sheet1!$B$1</c:f>
+              <c:strCache>
+                <c:ptCount val="1"/>
+                <c:pt idx="0">
+                  <c:v>Cuota</c:v>
+                </c:pt>
+              </c:strCache>
+            </c:strRef>
+          </c:tx>
+          <c:cat>
+            <c:strRef>
+              <c:f>Sheet1!$A$2:$A$4</c:f>
+              <c:strCache>
+                <c:ptCount val="3"/>
+                <c:pt idx="0">
+                  <c:v>A</c:v>
+                </c:pt>
+                <c:pt idx="1">
+                  <c:v>B</c:v>
+                </c:pt>
+                <c:pt idx="2">
+                  <c:v>C</c:v>
+                </c:pt>
+              </c:strCache>
+            </c:strRef>
+          </c:cat>
+          <c:val>
+            <c:numRef>
+              <c:f>Sheet1!$B$2:$B$4</c:f>
+              <c:numCache>
+                <c:formatCode>General</c:formatCode>
+                <c:ptCount val="3"/>
+                <c:pt idx="0">
+                  <c:v>55</c:v>
+                </c:pt>
+                <c:pt idx="1">
+                  <c:v>30</c:v>
+                </c:pt>
+                <c:pt idx="2">
+                  <c:v>15</c:v>
+                </c:pt>
+              </c:numCache>
+            </c:numRef>
+          </c:val>
+        </c:ser>
+        <c:dLbls>
+          <c:numFmt formatCode="0%" sourceLinked="0"/>
+          <c:showLegendKey val="0"/>
+          <c:showVal val="1"/>
+          <c:showCatName val="0"/>
+          <c:showSerName val="0"/>
+          <c:showPercent val="1"/>
+          <c:showBubbleSize val="0"/>
+          <c:showLeaderLines val="1"/>
+        </c:dLbls>
+      </c:pieChart>
+    </c:plotArea>
+    <c:legend>
+      <c:legendPos/>
+    </c:legend>
+    <c:dispBlanksAs val="gap"/>
+  </c:chart>
+  <c:txPr>
+    <a:bodyPr/>
+    <a:lstStyle/>
+    <a:p>
+      <a:pPr>
+        <a:defRPr sz="1800"/>
+      </a:pPr>
+      <a:endParaRPr lang="en-US"/>
+    </a:p>
+  </c:txPr>
+  <c:externalData r:id="rId1">
+    <c:autoUpdate val="0"/>
+  </c:externalData>
+</c:chartSpace>
 </file>
 
 <file path=ppt/slideLayouts/slideLayout1.xml><?xml version="1.0" encoding="utf-8"?>
@@ -3762,6 +4044,81 @@
           </a:p>
         </p:txBody>
       </p:sp>
+    </p:spTree>
+  </p:cSld>
+  <p:clrMapOvr>
+    <a:masterClrMapping/>
+  </p:clrMapOvr>
+</p:sld>
+</file>
+
+<file path=ppt/slides/slide6.xml><?xml version="1.0" encoding="utf-8"?>
+<p:sld xmlns:a="http://schemas.openxmlformats.org/drawingml/2006/main" xmlns:p="http://schemas.openxmlformats.org/presentationml/2006/main" xmlns:r="http://schemas.openxmlformats.org/officeDocument/2006/relationships">
+  <p:cSld>
+    <p:spTree>
+      <p:nvGrpSpPr>
+        <p:cNvPr id="1" name=""/>
+        <p:cNvGrpSpPr/>
+        <p:nvPr/>
+      </p:nvGrpSpPr>
+      <p:grpSpPr/>
+      <p:sp>
+        <p:nvSpPr>
+          <p:cNvPr id="2" name="Title 1"/>
+          <p:cNvSpPr>
+            <a:spLocks noGrp="1"/>
+          </p:cNvSpPr>
+          <p:nvPr>
+            <p:ph type="title"/>
+          </p:nvPr>
+        </p:nvSpPr>
+        <p:spPr/>
+        <p:txBody>
+          <a:bodyPr/>
+          <a:lstStyle/>
+          <a:p>
+            <a:r>
+              <a:t>Gráficos</a:t>
+            </a:r>
+          </a:p>
+        </p:txBody>
+      </p:sp>
+      <p:graphicFrame>
+        <p:nvGraphicFramePr>
+          <p:cNvPr id="3" name="Chart 2"/>
+          <p:cNvGraphicFramePr>
+            <a:graphicFrameLocks noGrp="1"/>
+          </p:cNvGraphicFramePr>
+          <p:nvPr/>
+        </p:nvGraphicFramePr>
+        <p:xfrm>
+          <a:off x="548640" y="1463040"/>
+          <a:ext cx="5486400" cy="4206240"/>
+        </p:xfrm>
+        <a:graphic>
+          <a:graphicData uri="http://schemas.openxmlformats.org/drawingml/2006/chart">
+            <c:chart xmlns:c="http://schemas.openxmlformats.org/drawingml/2006/chart" r:id="rId2"/>
+          </a:graphicData>
+        </a:graphic>
+      </p:graphicFrame>
+      <p:graphicFrame>
+        <p:nvGraphicFramePr>
+          <p:cNvPr id="4" name="Chart 3"/>
+          <p:cNvGraphicFramePr>
+            <a:graphicFrameLocks noGrp="1"/>
+          </p:cNvGraphicFramePr>
+          <p:nvPr/>
+        </p:nvGraphicFramePr>
+        <p:xfrm>
+          <a:off x="6400800" y="1463040"/>
+          <a:ext cx="5120640" cy="4206240"/>
+        </p:xfrm>
+        <a:graphic>
+          <a:graphicData uri="http://schemas.openxmlformats.org/drawingml/2006/chart">
+            <c:chart xmlns:c="http://schemas.openxmlformats.org/drawingml/2006/chart" r:id="rId3"/>
+          </a:graphicData>
+        </a:graphic>
+      </p:graphicFrame>
     </p:spTree>
   </p:cSld>
   <p:clrMapOvr>

</xml_diff>